<commit_message>
PPTX-QA: clamp 7 off-canvas shapes on slides 3 and 4
</commit_message>
<xml_diff>
--- a/ETIW/easter_etiw.pptx
+++ b/ETIW/easter_etiw.pptx
@@ -7461,65 +7461,65 @@
 </file>
 
 <file path=ppt/slides/slide3.xml><?xml version="1.0" encoding="utf-8"?>
-<p:sld xmlns:a="http://schemas.openxmlformats.org/drawingml/2006/main" xmlns:r="http://schemas.openxmlformats.org/officeDocument/2006/relationships" xmlns:p="http://schemas.openxmlformats.org/presentationml/2006/main">
-  <p:cSld>
-    <p:bg>
-      <p:bgPr>
+<sld xmlns="http://schemas.openxmlformats.org/presentationml/2006/main" xmlns:a="http://schemas.openxmlformats.org/drawingml/2006/main" xmlns:ns2="http://schemas.microsoft.com/office/drawing/2014/main" xmlns:ns3="http://schemas.microsoft.com/office/powerpoint/2010/main">
+  <cSld>
+    <bg>
+      <bgPr>
         <a:solidFill>
           <a:schemeClr val="bg1"/>
         </a:solidFill>
         <a:effectLst/>
-      </p:bgPr>
-    </p:bg>
-    <p:spTree>
-      <p:nvGrpSpPr>
-        <p:cNvPr id="1" name=""/>
-        <p:cNvGrpSpPr/>
-        <p:nvPr/>
-      </p:nvGrpSpPr>
-      <p:grpSpPr>
+      </bgPr>
+    </bg>
+    <spTree>
+      <nvGrpSpPr>
+        <cNvPr id="1" name=""/>
+        <cNvGrpSpPr/>
+        <nvPr/>
+      </nvGrpSpPr>
+      <grpSpPr>
         <a:xfrm>
           <a:off x="0" y="0"/>
           <a:ext cx="0" cy="0"/>
           <a:chOff x="0" y="0"/>
           <a:chExt cx="0" cy="0"/>
         </a:xfrm>
-      </p:grpSpPr>
-      <p:grpSp>
-        <p:nvGrpSpPr>
-          <p:cNvPr id="15" name="Group 14">
-            <a:extLst>
-              <a:ext uri="{FF2B5EF4-FFF2-40B4-BE49-F238E27FC236}">
-                <a16:creationId xmlns:a16="http://schemas.microsoft.com/office/drawing/2014/main" id="{74D5ABAC-AAF9-CBA3-0429-F15CA84DA654}"/>
-              </a:ext>
-            </a:extLst>
-          </p:cNvPr>
-          <p:cNvGrpSpPr/>
-          <p:nvPr/>
-        </p:nvGrpSpPr>
-        <p:grpSpPr>
+      </grpSpPr>
+      <grpSp>
+        <nvGrpSpPr>
+          <cNvPr id="15" name="Group 14">
+            <a:extLst>
+              <a:ext uri="{FF2B5EF4-FFF2-40B4-BE49-F238E27FC236}">
+                <ns2:creationId id="{74D5ABAC-AAF9-CBA3-0429-F15CA84DA654}"/>
+              </a:ext>
+            </a:extLst>
+          </cNvPr>
+          <cNvGrpSpPr/>
+          <nvPr/>
+        </nvGrpSpPr>
+        <grpSpPr>
           <a:xfrm>
             <a:off x="48498" y="732092"/>
             <a:ext cx="3108588" cy="4494426"/>
             <a:chOff x="168143" y="732092"/>
             <a:chExt cx="3108588" cy="4494426"/>
           </a:xfrm>
-        </p:grpSpPr>
-        <p:sp>
-          <p:nvSpPr>
-            <p:cNvPr id="4" name="Content Placeholder 2">
+        </grpSpPr>
+        <sp>
+          <nvSpPr>
+            <cNvPr id="4" name="Content Placeholder 2">
               <a:extLst>
                 <a:ext uri="{FF2B5EF4-FFF2-40B4-BE49-F238E27FC236}">
-                  <a16:creationId xmlns:a16="http://schemas.microsoft.com/office/drawing/2014/main" id="{044B5DBC-0DD4-09F9-FCC4-C0CF0CFDD9D5}"/>
+                  <ns2:creationId id="{044B5DBC-0DD4-09F9-FCC4-C0CF0CFDD9D5}"/>
                 </a:ext>
               </a:extLst>
-            </p:cNvPr>
-            <p:cNvSpPr txBox="1">
+            </cNvPr>
+            <cNvSpPr txBox="1">
               <a:spLocks/>
-            </p:cNvSpPr>
-            <p:nvPr/>
-          </p:nvSpPr>
-          <p:spPr>
+            </cNvSpPr>
+            <nvPr/>
+          </nvSpPr>
+          <spPr>
             <a:xfrm>
               <a:off x="168143" y="2507423"/>
               <a:ext cx="3108588" cy="2719095"/>
@@ -7527,8 +7527,8 @@
             <a:prstGeom prst="rect">
               <a:avLst/>
             </a:prstGeom>
-          </p:spPr>
-          <p:txBody>
+          </spPr>
+          <txBody>
             <a:bodyPr/>
             <a:lstStyle>
               <a:lvl1pPr marL="171450" indent="-171450" algn="l" defTabSz="685800" rtl="0" eaLnBrk="1" latinLnBrk="0" hangingPunct="1">
@@ -7709,21 +7709,21 @@
               </a:pPr>
               <a:endParaRPr lang="en-GB" sz="1706" b="1" dirty="0"/>
             </a:p>
-          </p:txBody>
-        </p:sp>
-        <p:sp>
-          <p:nvSpPr>
-            <p:cNvPr id="5" name="TextBox 4">
+          </txBody>
+        </sp>
+        <sp>
+          <nvSpPr>
+            <cNvPr id="5" name="TextBox 4">
               <a:extLst>
                 <a:ext uri="{FF2B5EF4-FFF2-40B4-BE49-F238E27FC236}">
-                  <a16:creationId xmlns:a16="http://schemas.microsoft.com/office/drawing/2014/main" id="{DCF4729F-39C0-63EC-AEF1-EA7968C6B153}"/>
+                  <ns2:creationId id="{DCF4729F-39C0-63EC-AEF1-EA7968C6B153}"/>
                 </a:ext>
               </a:extLst>
-            </p:cNvPr>
-            <p:cNvSpPr txBox="1"/>
-            <p:nvPr/>
-          </p:nvSpPr>
-          <p:spPr>
+            </cNvPr>
+            <cNvSpPr txBox="1"/>
+            <nvPr/>
+          </nvSpPr>
+          <spPr>
             <a:xfrm>
               <a:off x="222885" y="1191053"/>
               <a:ext cx="2934201" cy="992836"/>
@@ -7732,8 +7732,8 @@
               <a:avLst/>
             </a:prstGeom>
             <a:noFill/>
-          </p:spPr>
-          <p:txBody>
+          </spPr>
+          <txBody>
             <a:bodyPr wrap="square" rtlCol="0">
               <a:spAutoFit/>
             </a:bodyPr>
@@ -7744,21 +7744,21 @@
                 <a:t>Read the text, slowly, in chunks, without making it clear where sentences start or end or adding any punctation in your reading.</a:t>
               </a:r>
             </a:p>
-          </p:txBody>
-        </p:sp>
-        <p:sp>
-          <p:nvSpPr>
-            <p:cNvPr id="6" name="TextBox 5">
+          </txBody>
+        </sp>
+        <sp>
+          <nvSpPr>
+            <cNvPr id="6" name="TextBox 5">
               <a:extLst>
                 <a:ext uri="{FF2B5EF4-FFF2-40B4-BE49-F238E27FC236}">
-                  <a16:creationId xmlns:a16="http://schemas.microsoft.com/office/drawing/2014/main" id="{AF638FD6-A5F6-1672-FFA4-DF4239B522F6}"/>
+                  <ns2:creationId id="{AF638FD6-A5F6-1672-FFA4-DF4239B522F6}"/>
                 </a:ext>
               </a:extLst>
-            </p:cNvPr>
-            <p:cNvSpPr txBox="1"/>
-            <p:nvPr/>
-          </p:nvSpPr>
-          <p:spPr>
+            </cNvPr>
+            <cNvSpPr txBox="1"/>
+            <nvPr/>
+          </nvSpPr>
+          <spPr>
             <a:xfrm>
               <a:off x="222885" y="732092"/>
               <a:ext cx="1562802" cy="317459"/>
@@ -7767,8 +7767,8 @@
               <a:avLst/>
             </a:prstGeom>
             <a:noFill/>
-          </p:spPr>
-          <p:txBody>
+          </spPr>
+          <txBody>
             <a:bodyPr wrap="square" rtlCol="0">
               <a:spAutoFit/>
             </a:bodyPr>
@@ -7779,44 +7779,44 @@
                 <a:t>Teacher Copy</a:t>
               </a:r>
             </a:p>
-          </p:txBody>
-        </p:sp>
-      </p:grpSp>
-      <p:grpSp>
-        <p:nvGrpSpPr>
-          <p:cNvPr id="16" name="Group 15">
-            <a:extLst>
-              <a:ext uri="{FF2B5EF4-FFF2-40B4-BE49-F238E27FC236}">
-                <a16:creationId xmlns:a16="http://schemas.microsoft.com/office/drawing/2014/main" id="{A758F7D9-AD31-04CE-F055-4C0B3C6B8DE8}"/>
-              </a:ext>
-            </a:extLst>
-          </p:cNvPr>
-          <p:cNvGrpSpPr/>
-          <p:nvPr/>
-        </p:nvGrpSpPr>
-        <p:grpSpPr>
+          </txBody>
+        </sp>
+      </grpSp>
+      <grpSp>
+        <nvGrpSpPr>
+          <cNvPr id="16" name="Group 15">
+            <a:extLst>
+              <a:ext uri="{FF2B5EF4-FFF2-40B4-BE49-F238E27FC236}">
+                <ns2:creationId id="{A758F7D9-AD31-04CE-F055-4C0B3C6B8DE8}"/>
+              </a:ext>
+            </a:extLst>
+          </cNvPr>
+          <cNvGrpSpPr/>
+          <nvPr/>
+        </nvGrpSpPr>
+        <grpSpPr>
           <a:xfrm>
             <a:off x="3460860" y="732092"/>
             <a:ext cx="3108588" cy="4494426"/>
             <a:chOff x="3520683" y="732092"/>
             <a:chExt cx="3108588" cy="4494426"/>
           </a:xfrm>
-        </p:grpSpPr>
-        <p:sp>
-          <p:nvSpPr>
-            <p:cNvPr id="2" name="Content Placeholder 2">
+        </grpSpPr>
+        <sp>
+          <nvSpPr>
+            <cNvPr id="2" name="Content Placeholder 2">
               <a:extLst>
                 <a:ext uri="{FF2B5EF4-FFF2-40B4-BE49-F238E27FC236}">
-                  <a16:creationId xmlns:a16="http://schemas.microsoft.com/office/drawing/2014/main" id="{B9990E91-64AD-F738-F8C1-817E34CA206F}"/>
+                  <ns2:creationId id="{B9990E91-64AD-F738-F8C1-817E34CA206F}"/>
                 </a:ext>
               </a:extLst>
-            </p:cNvPr>
-            <p:cNvSpPr txBox="1">
+            </cNvPr>
+            <cNvSpPr txBox="1">
               <a:spLocks/>
-            </p:cNvSpPr>
-            <p:nvPr/>
-          </p:nvSpPr>
-          <p:spPr>
+            </cNvSpPr>
+            <nvPr/>
+          </nvSpPr>
+          <spPr>
             <a:xfrm>
               <a:off x="3520683" y="2507423"/>
               <a:ext cx="3108588" cy="2719095"/>
@@ -7824,8 +7824,8 @@
             <a:prstGeom prst="rect">
               <a:avLst/>
             </a:prstGeom>
-          </p:spPr>
-          <p:txBody>
+          </spPr>
+          <txBody>
             <a:bodyPr/>
             <a:lstStyle>
               <a:lvl1pPr marL="171450" indent="-171450" algn="l" defTabSz="685800" rtl="0" eaLnBrk="1" latinLnBrk="0" hangingPunct="1">
@@ -8006,21 +8006,21 @@
               </a:pPr>
               <a:endParaRPr lang="en-GB" sz="1706" b="1" dirty="0"/>
             </a:p>
-          </p:txBody>
-        </p:sp>
-        <p:sp>
-          <p:nvSpPr>
-            <p:cNvPr id="3" name="TextBox 2">
+          </txBody>
+        </sp>
+        <sp>
+          <nvSpPr>
+            <cNvPr id="3" name="TextBox 2">
               <a:extLst>
                 <a:ext uri="{FF2B5EF4-FFF2-40B4-BE49-F238E27FC236}">
-                  <a16:creationId xmlns:a16="http://schemas.microsoft.com/office/drawing/2014/main" id="{49CCB030-4718-790A-9002-0B3BC105B62B}"/>
+                  <ns2:creationId id="{49CCB030-4718-790A-9002-0B3BC105B62B}"/>
                 </a:ext>
               </a:extLst>
-            </p:cNvPr>
-            <p:cNvSpPr txBox="1"/>
-            <p:nvPr/>
-          </p:nvSpPr>
-          <p:spPr>
+            </cNvPr>
+            <cNvSpPr txBox="1"/>
+            <nvPr/>
+          </nvSpPr>
+          <spPr>
             <a:xfrm>
               <a:off x="3575425" y="1191053"/>
               <a:ext cx="2934201" cy="992836"/>
@@ -8029,8 +8029,8 @@
               <a:avLst/>
             </a:prstGeom>
             <a:noFill/>
-          </p:spPr>
-          <p:txBody>
+          </spPr>
+          <txBody>
             <a:bodyPr wrap="square" rtlCol="0">
               <a:spAutoFit/>
             </a:bodyPr>
@@ -8041,21 +8041,21 @@
                 <a:t>Read the text, slowly, in chunks, without making it clear where sentences start or end or adding any punctation in your reading.</a:t>
               </a:r>
             </a:p>
-          </p:txBody>
-        </p:sp>
-        <p:sp>
-          <p:nvSpPr>
-            <p:cNvPr id="11" name="TextBox 10">
+          </txBody>
+        </sp>
+        <sp>
+          <nvSpPr>
+            <cNvPr id="11" name="TextBox 10">
               <a:extLst>
                 <a:ext uri="{FF2B5EF4-FFF2-40B4-BE49-F238E27FC236}">
-                  <a16:creationId xmlns:a16="http://schemas.microsoft.com/office/drawing/2014/main" id="{AB8C2834-539C-787B-91F0-12B2AD961176}"/>
+                  <ns2:creationId id="{AB8C2834-539C-787B-91F0-12B2AD961176}"/>
                 </a:ext>
               </a:extLst>
-            </p:cNvPr>
-            <p:cNvSpPr txBox="1"/>
-            <p:nvPr/>
-          </p:nvSpPr>
-          <p:spPr>
+            </cNvPr>
+            <cNvSpPr txBox="1"/>
+            <nvPr/>
+          </nvSpPr>
+          <spPr>
             <a:xfrm>
               <a:off x="3575425" y="732092"/>
               <a:ext cx="1562802" cy="317459"/>
@@ -8064,8 +8064,8 @@
               <a:avLst/>
             </a:prstGeom>
             <a:noFill/>
-          </p:spPr>
-          <p:txBody>
+          </spPr>
+          <txBody>
             <a:bodyPr wrap="square" rtlCol="0">
               <a:spAutoFit/>
             </a:bodyPr>
@@ -8076,53 +8076,53 @@
                 <a:t>Teacher Copy</a:t>
               </a:r>
             </a:p>
-          </p:txBody>
-        </p:sp>
-      </p:grpSp>
-      <p:grpSp>
-        <p:nvGrpSpPr>
-          <p:cNvPr id="17" name="Group 16">
-            <a:extLst>
-              <a:ext uri="{FF2B5EF4-FFF2-40B4-BE49-F238E27FC236}">
-                <a16:creationId xmlns:a16="http://schemas.microsoft.com/office/drawing/2014/main" id="{6E09C0B2-B0F5-2694-FB53-4BC58B4CCF57}"/>
-              </a:ext>
-            </a:extLst>
-          </p:cNvPr>
-          <p:cNvGrpSpPr/>
-          <p:nvPr/>
-        </p:nvGrpSpPr>
-        <p:grpSpPr>
+          </txBody>
+        </sp>
+      </grpSp>
+      <grpSp>
+        <nvGrpSpPr>
+          <cNvPr id="17" name="Group 16">
+            <a:extLst>
+              <a:ext uri="{FF2B5EF4-FFF2-40B4-BE49-F238E27FC236}">
+                <ns2:creationId id="{6E09C0B2-B0F5-2694-FB53-4BC58B4CCF57}"/>
+              </a:ext>
+            </a:extLst>
+          </cNvPr>
+          <cNvGrpSpPr/>
+          <nvPr/>
+        </nvGrpSpPr>
+        <grpSpPr>
           <a:xfrm>
             <a:off x="6873223" y="732092"/>
             <a:ext cx="3108588" cy="4494426"/>
             <a:chOff x="6873223" y="732092"/>
             <a:chExt cx="3108588" cy="4494426"/>
           </a:xfrm>
-        </p:grpSpPr>
-        <p:sp>
-          <p:nvSpPr>
-            <p:cNvPr id="12" name="Content Placeholder 2">
+        </grpSpPr>
+        <sp>
+          <nvSpPr>
+            <cNvPr id="12" name="Content Placeholder 2">
               <a:extLst>
                 <a:ext uri="{FF2B5EF4-FFF2-40B4-BE49-F238E27FC236}">
-                  <a16:creationId xmlns:a16="http://schemas.microsoft.com/office/drawing/2014/main" id="{EEF804B6-4AC4-EA64-28A9-FA3BBB0A8E17}"/>
+                  <ns2:creationId id="{EEF804B6-4AC4-EA64-28A9-FA3BBB0A8E17}"/>
                 </a:ext>
               </a:extLst>
-            </p:cNvPr>
-            <p:cNvSpPr txBox="1">
+            </cNvPr>
+            <cNvSpPr txBox="1">
               <a:spLocks/>
-            </p:cNvSpPr>
-            <p:nvPr/>
-          </p:nvSpPr>
-          <p:spPr>
+            </cNvSpPr>
+            <nvPr/>
+          </nvSpPr>
+          <spPr>
             <a:xfrm>
               <a:off x="6873223" y="2507423"/>
-              <a:ext cx="3108588" cy="2719095"/>
+              <a:ext cx="3032777" cy="2719095"/>
             </a:xfrm>
             <a:prstGeom prst="rect">
               <a:avLst/>
             </a:prstGeom>
-          </p:spPr>
-          <p:txBody>
+          </spPr>
+          <txBody>
             <a:bodyPr/>
             <a:lstStyle>
               <a:lvl1pPr marL="171450" indent="-171450" algn="l" defTabSz="685800" rtl="0" eaLnBrk="1" latinLnBrk="0" hangingPunct="1">
@@ -8303,21 +8303,21 @@
               </a:pPr>
               <a:endParaRPr lang="en-GB" sz="1706" b="1" dirty="0"/>
             </a:p>
-          </p:txBody>
-        </p:sp>
-        <p:sp>
-          <p:nvSpPr>
-            <p:cNvPr id="13" name="TextBox 12">
+          </txBody>
+        </sp>
+        <sp>
+          <nvSpPr>
+            <cNvPr id="13" name="TextBox 12">
               <a:extLst>
                 <a:ext uri="{FF2B5EF4-FFF2-40B4-BE49-F238E27FC236}">
-                  <a16:creationId xmlns:a16="http://schemas.microsoft.com/office/drawing/2014/main" id="{C3BC12BC-248F-F71B-5BBB-CC7A31B32BFF}"/>
+                  <ns2:creationId id="{C3BC12BC-248F-F71B-5BBB-CC7A31B32BFF}"/>
                 </a:ext>
               </a:extLst>
-            </p:cNvPr>
-            <p:cNvSpPr txBox="1"/>
-            <p:nvPr/>
-          </p:nvSpPr>
-          <p:spPr>
+            </cNvPr>
+            <cNvSpPr txBox="1"/>
+            <nvPr/>
+          </nvSpPr>
+          <spPr>
             <a:xfrm>
               <a:off x="6927965" y="1191053"/>
               <a:ext cx="2934201" cy="992836"/>
@@ -8326,8 +8326,8 @@
               <a:avLst/>
             </a:prstGeom>
             <a:noFill/>
-          </p:spPr>
-          <p:txBody>
+          </spPr>
+          <txBody>
             <a:bodyPr wrap="square" rtlCol="0">
               <a:spAutoFit/>
             </a:bodyPr>
@@ -8338,21 +8338,21 @@
                 <a:t>Read the text, slowly, in chunks, without making it clear where sentences start or end or adding any punctation in your reading.</a:t>
               </a:r>
             </a:p>
-          </p:txBody>
-        </p:sp>
-        <p:sp>
-          <p:nvSpPr>
-            <p:cNvPr id="14" name="TextBox 13">
+          </txBody>
+        </sp>
+        <sp>
+          <nvSpPr>
+            <cNvPr id="14" name="TextBox 13">
               <a:extLst>
                 <a:ext uri="{FF2B5EF4-FFF2-40B4-BE49-F238E27FC236}">
-                  <a16:creationId xmlns:a16="http://schemas.microsoft.com/office/drawing/2014/main" id="{6837CDC1-102A-8A20-0425-5F17B16DE751}"/>
+                  <ns2:creationId id="{6837CDC1-102A-8A20-0425-5F17B16DE751}"/>
                 </a:ext>
               </a:extLst>
-            </p:cNvPr>
-            <p:cNvSpPr txBox="1"/>
-            <p:nvPr/>
-          </p:nvSpPr>
-          <p:spPr>
+            </cNvPr>
+            <cNvSpPr txBox="1"/>
+            <nvPr/>
+          </nvSpPr>
+          <spPr>
             <a:xfrm>
               <a:off x="6927965" y="732092"/>
               <a:ext cx="1562802" cy="317459"/>
@@ -8361,8 +8361,8 @@
               <a:avLst/>
             </a:prstGeom>
             <a:noFill/>
-          </p:spPr>
-          <p:txBody>
+          </spPr>
+          <txBody>
             <a:bodyPr wrap="square" rtlCol="0">
               <a:spAutoFit/>
             </a:bodyPr>
@@ -8373,68 +8373,68 @@
                 <a:t>Teacher Copy</a:t>
               </a:r>
             </a:p>
-          </p:txBody>
-        </p:sp>
-      </p:grpSp>
-    </p:spTree>
-    <p:extLst>
-      <p:ext uri="{BB962C8B-B14F-4D97-AF65-F5344CB8AC3E}">
-        <p14:creationId xmlns:p14="http://schemas.microsoft.com/office/powerpoint/2010/main" val="3781829289"/>
-      </p:ext>
-    </p:extLst>
-  </p:cSld>
-  <p:clrMapOvr>
+          </txBody>
+        </sp>
+      </grpSp>
+    </spTree>
+    <extLst>
+      <ext uri="{BB962C8B-B14F-4D97-AF65-F5344CB8AC3E}">
+        <ns3:creationId val="3781829289"/>
+      </ext>
+    </extLst>
+  </cSld>
+  <clrMapOvr>
     <a:masterClrMapping/>
-  </p:clrMapOvr>
-</p:sld>
+  </clrMapOvr>
+</sld>
 </file>
 
 <file path=ppt/slides/slide4.xml><?xml version="1.0" encoding="utf-8"?>
-<p:sld xmlns:a="http://schemas.openxmlformats.org/drawingml/2006/main" xmlns:r="http://schemas.openxmlformats.org/officeDocument/2006/relationships" xmlns:p="http://schemas.openxmlformats.org/presentationml/2006/main">
-  <p:cSld>
-    <p:bg>
-      <p:bgPr>
+<sld xmlns="http://schemas.openxmlformats.org/presentationml/2006/main" xmlns:a="http://schemas.openxmlformats.org/drawingml/2006/main" xmlns:ns2="http://schemas.microsoft.com/office/drawing/2014/main" xmlns:ns3="http://schemas.openxmlformats.org/officeDocument/2006/relationships" xmlns:ns4="http://schemas.microsoft.com/office/powerpoint/2010/main">
+  <cSld>
+    <bg>
+      <bgPr>
         <a:solidFill>
           <a:schemeClr val="bg1"/>
         </a:solidFill>
         <a:effectLst/>
-      </p:bgPr>
-    </p:bg>
-    <p:spTree>
-      <p:nvGrpSpPr>
-        <p:cNvPr id="1" name=""/>
-        <p:cNvGrpSpPr/>
-        <p:nvPr/>
-      </p:nvGrpSpPr>
-      <p:grpSpPr>
+      </bgPr>
+    </bg>
+    <spTree>
+      <nvGrpSpPr>
+        <cNvPr id="1" name=""/>
+        <cNvGrpSpPr/>
+        <nvPr/>
+      </nvGrpSpPr>
+      <grpSpPr>
         <a:xfrm>
           <a:off x="0" y="0"/>
           <a:ext cx="0" cy="0"/>
           <a:chOff x="0" y="0"/>
           <a:chExt cx="0" cy="0"/>
         </a:xfrm>
-      </p:grpSpPr>
-      <p:pic>
-        <p:nvPicPr>
-          <p:cNvPr id="16" name="Picture 15">
-            <a:extLst>
-              <a:ext uri="{FF2B5EF4-FFF2-40B4-BE49-F238E27FC236}">
-                <a16:creationId xmlns:a16="http://schemas.microsoft.com/office/drawing/2014/main" id="{EE8A51E4-828C-29CE-E362-9BEF5422A828}"/>
-              </a:ext>
-            </a:extLst>
-          </p:cNvPr>
-          <p:cNvPicPr>
+      </grpSpPr>
+      <pic>
+        <nvPicPr>
+          <cNvPr id="16" name="Picture 15">
+            <a:extLst>
+              <a:ext uri="{FF2B5EF4-FFF2-40B4-BE49-F238E27FC236}">
+                <ns2:creationId id="{EE8A51E4-828C-29CE-E362-9BEF5422A828}"/>
+              </a:ext>
+            </a:extLst>
+          </cNvPr>
+          <cNvPicPr>
             <a:picLocks noChangeAspect="1"/>
-          </p:cNvPicPr>
-          <p:nvPr/>
-        </p:nvPicPr>
-        <p:blipFill>
-          <a:blip r:embed="rId2"/>
+          </cNvPicPr>
+          <nvPr/>
+        </nvPicPr>
+        <blipFill>
+          <a:blip ns3:embed="rId2"/>
           <a:stretch>
             <a:fillRect/>
           </a:stretch>
-        </p:blipFill>
-        <p:spPr>
+        </blipFill>
+        <spPr>
           <a:xfrm>
             <a:off x="161602" y="5404590"/>
             <a:ext cx="4649549" cy="1160030"/>
@@ -8445,21 +8445,21 @@
           <a:solidFill>
             <a:schemeClr val="bg1"/>
           </a:solidFill>
-        </p:spPr>
-      </p:pic>
-      <p:sp>
-        <p:nvSpPr>
-          <p:cNvPr id="19" name="TextBox 18">
-            <a:extLst>
-              <a:ext uri="{FF2B5EF4-FFF2-40B4-BE49-F238E27FC236}">
-                <a16:creationId xmlns:a16="http://schemas.microsoft.com/office/drawing/2014/main" id="{F7AB3F45-FE8A-102D-67E8-F6F758098F5A}"/>
-              </a:ext>
-            </a:extLst>
-          </p:cNvPr>
-          <p:cNvSpPr txBox="1"/>
-          <p:nvPr/>
-        </p:nvSpPr>
-        <p:spPr>
+        </spPr>
+      </pic>
+      <sp>
+        <nvSpPr>
+          <cNvPr id="19" name="TextBox 18">
+            <a:extLst>
+              <a:ext uri="{FF2B5EF4-FFF2-40B4-BE49-F238E27FC236}">
+                <ns2:creationId id="{F7AB3F45-FE8A-102D-67E8-F6F758098F5A}"/>
+              </a:ext>
+            </a:extLst>
+          </cNvPr>
+          <cNvSpPr txBox="1"/>
+          <nvPr/>
+        </nvSpPr>
+        <spPr>
           <a:xfrm>
             <a:off x="111499" y="-34556"/>
             <a:ext cx="2359941" cy="317459"/>
@@ -8468,8 +8468,8 @@
             <a:avLst/>
           </a:prstGeom>
           <a:noFill/>
-        </p:spPr>
-        <p:txBody>
+        </spPr>
+        <txBody>
           <a:bodyPr wrap="none" rtlCol="0">
             <a:spAutoFit/>
           </a:bodyPr>
@@ -8489,21 +8489,21 @@
               <a:t>___________________</a:t>
             </a:r>
           </a:p>
-        </p:txBody>
-      </p:sp>
-      <p:sp>
-        <p:nvSpPr>
-          <p:cNvPr id="20" name="TextBox 19">
-            <a:extLst>
-              <a:ext uri="{FF2B5EF4-FFF2-40B4-BE49-F238E27FC236}">
-                <a16:creationId xmlns:a16="http://schemas.microsoft.com/office/drawing/2014/main" id="{C403BCAE-6903-1B26-3F6D-917F84E733F1}"/>
-              </a:ext>
-            </a:extLst>
-          </p:cNvPr>
-          <p:cNvSpPr txBox="1"/>
-          <p:nvPr/>
-        </p:nvSpPr>
-        <p:spPr>
+        </txBody>
+      </sp>
+      <sp>
+        <nvSpPr>
+          <cNvPr id="20" name="TextBox 19">
+            <a:extLst>
+              <a:ext uri="{FF2B5EF4-FFF2-40B4-BE49-F238E27FC236}">
+                <ns2:creationId id="{C403BCAE-6903-1B26-3F6D-917F84E733F1}"/>
+              </a:ext>
+            </a:extLst>
+          </cNvPr>
+          <cNvSpPr txBox="1"/>
+          <nvPr/>
+        </nvSpPr>
+        <spPr>
           <a:xfrm>
             <a:off x="7617253" y="5751689"/>
             <a:ext cx="2286203" cy="317459"/>
@@ -8512,8 +8512,8 @@
             <a:avLst/>
           </a:prstGeom>
           <a:noFill/>
-        </p:spPr>
-        <p:txBody>
+        </spPr>
+        <txBody>
           <a:bodyPr wrap="none" rtlCol="0">
             <a:spAutoFit/>
           </a:bodyPr>
@@ -8527,21 +8527,21 @@
               <a:t>___________________</a:t>
             </a:r>
           </a:p>
-        </p:txBody>
-      </p:sp>
-      <p:sp>
-        <p:nvSpPr>
-          <p:cNvPr id="21" name="TextBox 20">
-            <a:extLst>
-              <a:ext uri="{FF2B5EF4-FFF2-40B4-BE49-F238E27FC236}">
-                <a16:creationId xmlns:a16="http://schemas.microsoft.com/office/drawing/2014/main" id="{6662B234-06F4-FB6E-20B4-A504A8287FA0}"/>
-              </a:ext>
-            </a:extLst>
-          </p:cNvPr>
-          <p:cNvSpPr txBox="1"/>
-          <p:nvPr/>
-        </p:nvSpPr>
-        <p:spPr>
+        </txBody>
+      </sp>
+      <sp>
+        <nvSpPr>
+          <cNvPr id="21" name="TextBox 20">
+            <a:extLst>
+              <a:ext uri="{FF2B5EF4-FFF2-40B4-BE49-F238E27FC236}">
+                <ns2:creationId id="{6662B234-06F4-FB6E-20B4-A504A8287FA0}"/>
+              </a:ext>
+            </a:extLst>
+          </cNvPr>
+          <cNvSpPr txBox="1"/>
+          <nvPr/>
+        </nvSpPr>
+        <spPr>
           <a:xfrm>
             <a:off x="8060734" y="5982543"/>
             <a:ext cx="1273105" cy="317459"/>
@@ -8550,8 +8550,8 @@
             <a:avLst/>
           </a:prstGeom>
           <a:noFill/>
-        </p:spPr>
-        <p:txBody>
+        </spPr>
+        <txBody>
           <a:bodyPr wrap="none" rtlCol="0">
             <a:spAutoFit/>
           </a:bodyPr>
@@ -8565,23 +8565,23 @@
               <a:t>missing word</a:t>
             </a:r>
           </a:p>
-        </p:txBody>
-      </p:sp>
-      <p:cxnSp>
-        <p:nvCxnSpPr>
-          <p:cNvPr id="34" name="Straight Connector 33">
-            <a:extLst>
-              <a:ext uri="{FF2B5EF4-FFF2-40B4-BE49-F238E27FC236}">
-                <a16:creationId xmlns:a16="http://schemas.microsoft.com/office/drawing/2014/main" id="{0499CBFA-1C67-02FF-65DC-C997034DF579}"/>
-              </a:ext>
-            </a:extLst>
-          </p:cNvPr>
-          <p:cNvCxnSpPr>
+        </txBody>
+      </sp>
+      <cxnSp>
+        <nvCxnSpPr>
+          <cNvPr id="34" name="Straight Connector 33">
+            <a:extLst>
+              <a:ext uri="{FF2B5EF4-FFF2-40B4-BE49-F238E27FC236}">
+                <ns2:creationId id="{0499CBFA-1C67-02FF-65DC-C997034DF579}"/>
+              </a:ext>
+            </a:extLst>
+          </cNvPr>
+          <cNvCxnSpPr>
             <a:cxnSpLocks/>
-          </p:cNvCxnSpPr>
-          <p:nvPr/>
-        </p:nvCxnSpPr>
-        <p:spPr>
+          </cNvCxnSpPr>
+          <nvPr/>
+        </nvCxnSpPr>
+        <spPr>
           <a:xfrm>
             <a:off x="6869756" y="-563603"/>
             <a:ext cx="1437442" cy="0"/>
@@ -8594,8 +8594,8 @@
               <a:schemeClr val="tx1"/>
             </a:solidFill>
           </a:ln>
-        </p:spPr>
-        <p:style>
+        </spPr>
+        <style>
           <a:lnRef idx="1">
             <a:schemeClr val="accent1"/>
           </a:lnRef>
@@ -8608,31 +8608,31 @@
           <a:fontRef idx="minor">
             <a:schemeClr val="tx1"/>
           </a:fontRef>
-        </p:style>
-      </p:cxnSp>
-      <p:sp>
-        <p:nvSpPr>
-          <p:cNvPr id="7" name="Content Placeholder 6">
-            <a:extLst>
-              <a:ext uri="{FF2B5EF4-FFF2-40B4-BE49-F238E27FC236}">
-                <a16:creationId xmlns:a16="http://schemas.microsoft.com/office/drawing/2014/main" id="{05ED920F-3BE0-4CA1-F917-664CB2014C38}"/>
-              </a:ext>
-            </a:extLst>
-          </p:cNvPr>
-          <p:cNvSpPr>
+        </style>
+      </cxnSp>
+      <sp>
+        <nvSpPr>
+          <cNvPr id="7" name="Content Placeholder 6">
+            <a:extLst>
+              <a:ext uri="{FF2B5EF4-FFF2-40B4-BE49-F238E27FC236}">
+                <ns2:creationId id="{05ED920F-3BE0-4CA1-F917-664CB2014C38}"/>
+              </a:ext>
+            </a:extLst>
+          </cNvPr>
+          <cNvSpPr>
             <a:spLocks noGrp="1"/>
-          </p:cNvSpPr>
-          <p:nvPr>
-            <p:ph idx="1"/>
-          </p:nvPr>
-        </p:nvSpPr>
-        <p:spPr>
+          </cNvSpPr>
+          <nvPr>
+            <ph idx="1"/>
+          </nvPr>
+        </nvSpPr>
+        <spPr>
           <a:xfrm>
             <a:off x="-50104" y="491210"/>
             <a:ext cx="9906000" cy="4938429"/>
           </a:xfrm>
-        </p:spPr>
-        <p:txBody>
+        </spPr>
+        <txBody>
           <a:bodyPr>
             <a:normAutofit lnSpcReduction="10000"/>
           </a:bodyPr>
@@ -8717,24 +8717,24 @@
               <a:t>.</a:t>
             </a:r>
           </a:p>
-        </p:txBody>
-      </p:sp>
-      <p:sp>
-        <p:nvSpPr>
-          <p:cNvPr id="24" name="Rectangle 23">
-            <a:extLst>
-              <a:ext uri="{FF2B5EF4-FFF2-40B4-BE49-F238E27FC236}">
-                <a16:creationId xmlns:a16="http://schemas.microsoft.com/office/drawing/2014/main" id="{2626F6B0-77F5-25CB-9756-AFB02D4CFF92}"/>
-              </a:ext>
-            </a:extLst>
-          </p:cNvPr>
-          <p:cNvSpPr/>
-          <p:nvPr/>
-        </p:nvSpPr>
-        <p:spPr>
+        </txBody>
+      </sp>
+      <sp>
+        <nvSpPr>
+          <cNvPr id="24" name="Rectangle 23">
+            <a:extLst>
+              <a:ext uri="{FF2B5EF4-FFF2-40B4-BE49-F238E27FC236}">
+                <ns2:creationId id="{2626F6B0-77F5-25CB-9756-AFB02D4CFF92}"/>
+              </a:ext>
+            </a:extLst>
+          </cNvPr>
+          <cNvSpPr/>
+          <nvPr/>
+        </nvSpPr>
+        <spPr>
           <a:xfrm>
             <a:off x="-393004" y="862535"/>
-            <a:ext cx="10929938" cy="324000"/>
+            <a:ext cx="10299004" cy="324000"/>
           </a:xfrm>
           <a:prstGeom prst="rect">
             <a:avLst/>
@@ -8748,8 +8748,8 @@
               </a:schemeClr>
             </a:solidFill>
           </a:ln>
-        </p:spPr>
-        <p:style>
+        </spPr>
+        <style>
           <a:lnRef idx="2">
             <a:schemeClr val="accent1">
               <a:shade val="15000"/>
@@ -8764,32 +8764,32 @@
           <a:fontRef idx="minor">
             <a:schemeClr val="lt1"/>
           </a:fontRef>
-        </p:style>
-        <p:txBody>
+        </style>
+        <txBody>
           <a:bodyPr rtlCol="0" anchor="ctr"/>
           <a:lstStyle/>
           <a:p>
             <a:pPr algn="ctr"/>
             <a:endParaRPr lang="en-GB"/>
           </a:p>
-        </p:txBody>
-      </p:sp>
-      <p:sp>
-        <p:nvSpPr>
-          <p:cNvPr id="30" name="Rectangle 29">
-            <a:extLst>
-              <a:ext uri="{FF2B5EF4-FFF2-40B4-BE49-F238E27FC236}">
-                <a16:creationId xmlns:a16="http://schemas.microsoft.com/office/drawing/2014/main" id="{CF2A9127-0A11-4F95-0752-540917BCA6B8}"/>
-              </a:ext>
-            </a:extLst>
-          </p:cNvPr>
-          <p:cNvSpPr/>
-          <p:nvPr/>
-        </p:nvSpPr>
-        <p:spPr>
+        </txBody>
+      </sp>
+      <sp>
+        <nvSpPr>
+          <cNvPr id="30" name="Rectangle 29">
+            <a:extLst>
+              <a:ext uri="{FF2B5EF4-FFF2-40B4-BE49-F238E27FC236}">
+                <ns2:creationId id="{CF2A9127-0A11-4F95-0752-540917BCA6B8}"/>
+              </a:ext>
+            </a:extLst>
+          </cNvPr>
+          <cNvSpPr/>
+          <nvPr/>
+        </nvSpPr>
+        <spPr>
           <a:xfrm>
             <a:off x="-393004" y="1660777"/>
-            <a:ext cx="10929938" cy="324000"/>
+            <a:ext cx="10299004" cy="324000"/>
           </a:xfrm>
           <a:prstGeom prst="rect">
             <a:avLst/>
@@ -8803,8 +8803,8 @@
               </a:schemeClr>
             </a:solidFill>
           </a:ln>
-        </p:spPr>
-        <p:style>
+        </spPr>
+        <style>
           <a:lnRef idx="2">
             <a:schemeClr val="accent1">
               <a:shade val="15000"/>
@@ -8819,32 +8819,32 @@
           <a:fontRef idx="minor">
             <a:schemeClr val="lt1"/>
           </a:fontRef>
-        </p:style>
-        <p:txBody>
+        </style>
+        <txBody>
           <a:bodyPr rtlCol="0" anchor="ctr"/>
           <a:lstStyle/>
           <a:p>
             <a:pPr algn="ctr"/>
             <a:endParaRPr lang="en-GB"/>
           </a:p>
-        </p:txBody>
-      </p:sp>
-      <p:sp>
-        <p:nvSpPr>
-          <p:cNvPr id="35" name="Rectangle 34">
-            <a:extLst>
-              <a:ext uri="{FF2B5EF4-FFF2-40B4-BE49-F238E27FC236}">
-                <a16:creationId xmlns:a16="http://schemas.microsoft.com/office/drawing/2014/main" id="{5CC1414F-A78A-C3F4-C7F2-0D1F951F5AEE}"/>
-              </a:ext>
-            </a:extLst>
-          </p:cNvPr>
-          <p:cNvSpPr/>
-          <p:nvPr/>
-        </p:nvSpPr>
-        <p:spPr>
+        </txBody>
+      </sp>
+      <sp>
+        <nvSpPr>
+          <cNvPr id="35" name="Rectangle 34">
+            <a:extLst>
+              <a:ext uri="{FF2B5EF4-FFF2-40B4-BE49-F238E27FC236}">
+                <ns2:creationId id="{5CC1414F-A78A-C3F4-C7F2-0D1F951F5AEE}"/>
+              </a:ext>
+            </a:extLst>
+          </cNvPr>
+          <cNvSpPr/>
+          <nvPr/>
+        </nvSpPr>
+        <spPr>
           <a:xfrm>
             <a:off x="-393004" y="2484071"/>
-            <a:ext cx="10929938" cy="324000"/>
+            <a:ext cx="10299004" cy="324000"/>
           </a:xfrm>
           <a:prstGeom prst="rect">
             <a:avLst/>
@@ -8858,8 +8858,8 @@
               </a:schemeClr>
             </a:solidFill>
           </a:ln>
-        </p:spPr>
-        <p:style>
+        </spPr>
+        <style>
           <a:lnRef idx="2">
             <a:schemeClr val="accent1">
               <a:shade val="15000"/>
@@ -8874,32 +8874,32 @@
           <a:fontRef idx="minor">
             <a:schemeClr val="lt1"/>
           </a:fontRef>
-        </p:style>
-        <p:txBody>
+        </style>
+        <txBody>
           <a:bodyPr rtlCol="0" anchor="ctr"/>
           <a:lstStyle/>
           <a:p>
             <a:pPr algn="ctr"/>
             <a:endParaRPr lang="en-GB"/>
           </a:p>
-        </p:txBody>
-      </p:sp>
-      <p:sp>
-        <p:nvSpPr>
-          <p:cNvPr id="36" name="Rectangle 35">
-            <a:extLst>
-              <a:ext uri="{FF2B5EF4-FFF2-40B4-BE49-F238E27FC236}">
-                <a16:creationId xmlns:a16="http://schemas.microsoft.com/office/drawing/2014/main" id="{CFE571BD-78EB-221E-FDCF-54A9027DE1CF}"/>
-              </a:ext>
-            </a:extLst>
-          </p:cNvPr>
-          <p:cNvSpPr/>
-          <p:nvPr/>
-        </p:nvSpPr>
-        <p:spPr>
+        </txBody>
+      </sp>
+      <sp>
+        <nvSpPr>
+          <cNvPr id="36" name="Rectangle 35">
+            <a:extLst>
+              <a:ext uri="{FF2B5EF4-FFF2-40B4-BE49-F238E27FC236}">
+                <ns2:creationId id="{CFE571BD-78EB-221E-FDCF-54A9027DE1CF}"/>
+              </a:ext>
+            </a:extLst>
+          </cNvPr>
+          <cNvSpPr/>
+          <nvPr/>
+        </nvSpPr>
+        <spPr>
           <a:xfrm>
             <a:off x="-393004" y="3296601"/>
-            <a:ext cx="10929938" cy="324000"/>
+            <a:ext cx="10299004" cy="324000"/>
           </a:xfrm>
           <a:prstGeom prst="rect">
             <a:avLst/>
@@ -8913,8 +8913,8 @@
               </a:schemeClr>
             </a:solidFill>
           </a:ln>
-        </p:spPr>
-        <p:style>
+        </spPr>
+        <style>
           <a:lnRef idx="2">
             <a:schemeClr val="accent1">
               <a:shade val="15000"/>
@@ -8929,32 +8929,32 @@
           <a:fontRef idx="minor">
             <a:schemeClr val="lt1"/>
           </a:fontRef>
-        </p:style>
-        <p:txBody>
+        </style>
+        <txBody>
           <a:bodyPr rtlCol="0" anchor="ctr"/>
           <a:lstStyle/>
           <a:p>
             <a:pPr algn="ctr"/>
             <a:endParaRPr lang="en-GB"/>
           </a:p>
-        </p:txBody>
-      </p:sp>
-      <p:sp>
-        <p:nvSpPr>
-          <p:cNvPr id="38" name="Rectangle 37">
-            <a:extLst>
-              <a:ext uri="{FF2B5EF4-FFF2-40B4-BE49-F238E27FC236}">
-                <a16:creationId xmlns:a16="http://schemas.microsoft.com/office/drawing/2014/main" id="{08B68AF2-5688-E464-BA8B-A136D6930FC9}"/>
-              </a:ext>
-            </a:extLst>
-          </p:cNvPr>
-          <p:cNvSpPr/>
-          <p:nvPr/>
-        </p:nvSpPr>
-        <p:spPr>
+        </txBody>
+      </sp>
+      <sp>
+        <nvSpPr>
+          <cNvPr id="38" name="Rectangle 37">
+            <a:extLst>
+              <a:ext uri="{FF2B5EF4-FFF2-40B4-BE49-F238E27FC236}">
+                <ns2:creationId id="{08B68AF2-5688-E464-BA8B-A136D6930FC9}"/>
+              </a:ext>
+            </a:extLst>
+          </cNvPr>
+          <cNvSpPr/>
+          <nvPr/>
+        </nvSpPr>
+        <spPr>
           <a:xfrm>
             <a:off x="-393004" y="4094843"/>
-            <a:ext cx="10929938" cy="324000"/>
+            <a:ext cx="10299004" cy="324000"/>
           </a:xfrm>
           <a:prstGeom prst="rect">
             <a:avLst/>
@@ -8968,8 +8968,8 @@
               </a:schemeClr>
             </a:solidFill>
           </a:ln>
-        </p:spPr>
-        <p:style>
+        </spPr>
+        <style>
           <a:lnRef idx="2">
             <a:schemeClr val="accent1">
               <a:shade val="15000"/>
@@ -8984,32 +8984,32 @@
           <a:fontRef idx="minor">
             <a:schemeClr val="lt1"/>
           </a:fontRef>
-        </p:style>
-        <p:txBody>
+        </style>
+        <txBody>
           <a:bodyPr rtlCol="0" anchor="ctr"/>
           <a:lstStyle/>
           <a:p>
             <a:pPr algn="ctr"/>
             <a:endParaRPr lang="en-GB"/>
           </a:p>
-        </p:txBody>
-      </p:sp>
-      <p:sp>
-        <p:nvSpPr>
-          <p:cNvPr id="2" name="Rectangle 1">
-            <a:extLst>
-              <a:ext uri="{FF2B5EF4-FFF2-40B4-BE49-F238E27FC236}">
-                <a16:creationId xmlns:a16="http://schemas.microsoft.com/office/drawing/2014/main" id="{FE361980-7D06-60FC-19DE-C70CEAFC77DF}"/>
-              </a:ext>
-            </a:extLst>
-          </p:cNvPr>
-          <p:cNvSpPr/>
-          <p:nvPr/>
-        </p:nvSpPr>
-        <p:spPr>
+        </txBody>
+      </sp>
+      <sp>
+        <nvSpPr>
+          <cNvPr id="2" name="Rectangle 1">
+            <a:extLst>
+              <a:ext uri="{FF2B5EF4-FFF2-40B4-BE49-F238E27FC236}">
+                <ns2:creationId id="{FE361980-7D06-60FC-19DE-C70CEAFC77DF}"/>
+              </a:ext>
+            </a:extLst>
+          </cNvPr>
+          <cNvSpPr/>
+          <nvPr/>
+        </nvSpPr>
+        <spPr>
           <a:xfrm>
             <a:off x="-393004" y="4893085"/>
-            <a:ext cx="10929938" cy="324000"/>
+            <a:ext cx="10299004" cy="324000"/>
           </a:xfrm>
           <a:prstGeom prst="rect">
             <a:avLst/>
@@ -9023,8 +9023,8 @@
               </a:schemeClr>
             </a:solidFill>
           </a:ln>
-        </p:spPr>
-        <p:style>
+        </spPr>
+        <style>
           <a:lnRef idx="2">
             <a:schemeClr val="accent1">
               <a:shade val="15000"/>
@@ -9039,27 +9039,27 @@
           <a:fontRef idx="minor">
             <a:schemeClr val="lt1"/>
           </a:fontRef>
-        </p:style>
-        <p:txBody>
+        </style>
+        <txBody>
           <a:bodyPr rtlCol="0" anchor="ctr"/>
           <a:lstStyle/>
           <a:p>
             <a:pPr algn="ctr"/>
             <a:endParaRPr lang="en-GB"/>
           </a:p>
-        </p:txBody>
-      </p:sp>
-    </p:spTree>
-    <p:extLst>
-      <p:ext uri="{BB962C8B-B14F-4D97-AF65-F5344CB8AC3E}">
-        <p14:creationId xmlns:p14="http://schemas.microsoft.com/office/powerpoint/2010/main" val="969986789"/>
-      </p:ext>
-    </p:extLst>
-  </p:cSld>
-  <p:clrMapOvr>
+        </txBody>
+      </sp>
+    </spTree>
+    <extLst>
+      <ext uri="{BB962C8B-B14F-4D97-AF65-F5344CB8AC3E}">
+        <ns4:creationId val="969986789"/>
+      </ext>
+    </extLst>
+  </cSld>
+  <clrMapOvr>
     <a:masterClrMapping/>
-  </p:clrMapOvr>
-</p:sld>
+  </clrMapOvr>
+</sld>
 </file>
 
 <file path=ppt/slides/slide5.xml><?xml version="1.0" encoding="utf-8"?>

</xml_diff>